<commit_message>
added changes on 30-03-2026
</commit_message>
<xml_diff>
--- a/backend/src/templates/hpe-proposal-template.pptx
+++ b/backend/src/templates/hpe-proposal-template.pptx
@@ -19,14 +19,14 @@
   <p:notesSz cx="6858000" cy="9144000"/>
   <p:embeddedFontLst>
     <p:embeddedFont>
-      <p:font typeface="HPE Graphik" pitchFamily="50" charset="0"/>
+      <p:font typeface="HPE Graphik" panose="020B0604020202020204" charset="0"/>
       <p:regular r:id="rId10"/>
       <p:bold r:id="rId11"/>
       <p:italic r:id="rId12"/>
       <p:boldItalic r:id="rId13"/>
     </p:embeddedFont>
     <p:embeddedFont>
-      <p:font typeface="HPE Graphik Light" pitchFamily="50" charset="0"/>
+      <p:font typeface="HPE Graphik Light" panose="020B0604020202020204" charset="0"/>
       <p:regular r:id="rId14"/>
       <p:italic r:id="rId15"/>
     </p:embeddedFont>
@@ -137,7 +137,7 @@
             <p14:sldId id="256"/>
           </p14:sldIdLst>
         </p14:section>
-        <p14:section name="LAYOUT_CONTENT_BODY" id="{533A704A-4317-4096-AC88-58AB5351DFD4}">
+        <p14:section name="LAYOUT_CONTENT" id="{533A704A-4317-4096-AC88-58AB5351DFD4}">
           <p14:sldIdLst>
             <p14:sldId id="560"/>
           </p14:sldIdLst>
@@ -2363,11 +2363,11 @@
     <p:bg>
       <p:bgPr>
         <a:blipFill dpi="0" rotWithShape="1">
-          <a:blip r:embed="rId2">
+          <a:blip>
             <a:lum/>
             <a:extLst>
               <a:ext uri="{96DAC541-7B7A-43D3-8B79-37D633B846F1}">
-                <asvg:svgBlip xmlns:asvg="http://schemas.microsoft.com/office/drawing/2016/SVG/main" r:embed="rId3"/>
+                <asvg:svgBlip xmlns:asvg="http://schemas.microsoft.com/office/drawing/2016/SVG/main" r:embed="rId2"/>
               </a:ext>
             </a:extLst>
           </a:blip>
@@ -2501,7 +2501,7 @@
           <p:nvPr userDrawn="1"/>
         </p:nvPicPr>
         <p:blipFill>
-          <a:blip r:embed="rId4"/>
+          <a:blip r:embed="rId3"/>
           <a:stretch>
             <a:fillRect/>
           </a:stretch>
@@ -2733,11 +2733,11 @@
     <p:bg>
       <p:bgPr>
         <a:blipFill dpi="0" rotWithShape="1">
-          <a:blip r:embed="rId2">
+          <a:blip>
             <a:lum/>
             <a:extLst>
               <a:ext uri="{96DAC541-7B7A-43D3-8B79-37D633B846F1}">
-                <asvg:svgBlip xmlns:asvg="http://schemas.microsoft.com/office/drawing/2016/SVG/main" r:embed="rId3"/>
+                <asvg:svgBlip xmlns:asvg="http://schemas.microsoft.com/office/drawing/2016/SVG/main" r:embed="rId2"/>
               </a:ext>
             </a:extLst>
           </a:blip>
@@ -3100,10 +3100,10 @@
           <p:nvPr userDrawn="1"/>
         </p:nvPicPr>
         <p:blipFill>
-          <a:blip r:embed="rId2">
+          <a:blip>
             <a:extLst>
               <a:ext uri="{96DAC541-7B7A-43D3-8B79-37D633B846F1}">
-                <asvg:svgBlip xmlns:asvg="http://schemas.microsoft.com/office/drawing/2016/SVG/main" r:embed="rId3"/>
+                <asvg:svgBlip xmlns:asvg="http://schemas.microsoft.com/office/drawing/2016/SVG/main" r:embed="rId2"/>
               </a:ext>
             </a:extLst>
           </a:blip>
@@ -6185,11 +6185,11 @@
     <p:bg>
       <p:bgPr>
         <a:blipFill dpi="0" rotWithShape="1">
-          <a:blip r:embed="rId2">
+          <a:blip>
             <a:lum/>
             <a:extLst>
               <a:ext uri="{96DAC541-7B7A-43D3-8B79-37D633B846F1}">
-                <asvg:svgBlip xmlns:asvg="http://schemas.microsoft.com/office/drawing/2016/SVG/main" r:embed="rId3"/>
+                <asvg:svgBlip xmlns:asvg="http://schemas.microsoft.com/office/drawing/2016/SVG/main" r:embed="rId2"/>
               </a:ext>
             </a:extLst>
           </a:blip>
@@ -6323,7 +6323,7 @@
           <p:nvPr userDrawn="1"/>
         </p:nvPicPr>
         <p:blipFill>
-          <a:blip r:embed="rId4"/>
+          <a:blip r:embed="rId3"/>
           <a:stretch>
             <a:fillRect/>
           </a:stretch>
@@ -8957,10 +8957,10 @@
           <p:nvPr/>
         </p:nvPicPr>
         <p:blipFill>
-          <a:blip r:embed="rId2">
+          <a:blip>
             <a:extLst>
               <a:ext uri="{96DAC541-7B7A-43D3-8B79-37D633B846F1}">
-                <asvg:svgBlip xmlns:asvg="http://schemas.microsoft.com/office/drawing/2016/SVG/main" r:embed="rId3"/>
+                <asvg:svgBlip xmlns:asvg="http://schemas.microsoft.com/office/drawing/2016/SVG/main" r:embed="rId2"/>
               </a:ext>
             </a:extLst>
           </a:blip>
@@ -10192,10 +10192,10 @@
           <p:nvPr/>
         </p:nvPicPr>
         <p:blipFill>
-          <a:blip r:embed="rId2">
+          <a:blip>
             <a:extLst>
               <a:ext uri="{96DAC541-7B7A-43D3-8B79-37D633B846F1}">
-                <asvg:svgBlip xmlns:asvg="http://schemas.microsoft.com/office/drawing/2016/SVG/main" r:embed="rId3"/>
+                <asvg:svgBlip xmlns:asvg="http://schemas.microsoft.com/office/drawing/2016/SVG/main" r:embed="rId2"/>
               </a:ext>
             </a:extLst>
           </a:blip>
@@ -12587,11 +12587,11 @@
     <p:bg>
       <p:bgPr>
         <a:blipFill dpi="0" rotWithShape="1">
-          <a:blip r:embed="rId2">
+          <a:blip>
             <a:lum/>
             <a:extLst>
               <a:ext uri="{96DAC541-7B7A-43D3-8B79-37D633B846F1}">
-                <asvg:svgBlip xmlns:asvg="http://schemas.microsoft.com/office/drawing/2016/SVG/main" r:embed="rId3"/>
+                <asvg:svgBlip xmlns:asvg="http://schemas.microsoft.com/office/drawing/2016/SVG/main" r:embed="rId2"/>
               </a:ext>
             </a:extLst>
           </a:blip>
@@ -12725,7 +12725,7 @@
           <p:nvPr userDrawn="1"/>
         </p:nvPicPr>
         <p:blipFill>
-          <a:blip r:embed="rId4"/>
+          <a:blip r:embed="rId3"/>
           <a:stretch>
             <a:fillRect/>
           </a:stretch>
@@ -15439,10 +15439,10 @@
           <p:nvPr/>
         </p:nvPicPr>
         <p:blipFill>
-          <a:blip r:embed="rId2">
+          <a:blip>
             <a:extLst>
               <a:ext uri="{96DAC541-7B7A-43D3-8B79-37D633B846F1}">
-                <asvg:svgBlip xmlns:asvg="http://schemas.microsoft.com/office/drawing/2016/SVG/main" r:embed="rId3"/>
+                <asvg:svgBlip xmlns:asvg="http://schemas.microsoft.com/office/drawing/2016/SVG/main" r:embed="rId2"/>
               </a:ext>
             </a:extLst>
           </a:blip>
@@ -15778,10 +15778,10 @@
           <p:nvPr/>
         </p:nvPicPr>
         <p:blipFill>
-          <a:blip r:embed="rId2">
+          <a:blip>
             <a:extLst>
               <a:ext uri="{96DAC541-7B7A-43D3-8B79-37D633B846F1}">
-                <asvg:svgBlip xmlns:asvg="http://schemas.microsoft.com/office/drawing/2016/SVG/main" r:embed="rId3"/>
+                <asvg:svgBlip xmlns:asvg="http://schemas.microsoft.com/office/drawing/2016/SVG/main" r:embed="rId2"/>
               </a:ext>
             </a:extLst>
           </a:blip>
@@ -16485,11 +16485,11 @@
     <p:bg>
       <p:bgPr>
         <a:blipFill dpi="0" rotWithShape="1">
-          <a:blip r:embed="rId2">
+          <a:blip>
             <a:lum/>
             <a:extLst>
               <a:ext uri="{96DAC541-7B7A-43D3-8B79-37D633B846F1}">
-                <asvg:svgBlip xmlns:asvg="http://schemas.microsoft.com/office/drawing/2016/SVG/main" r:embed="rId3"/>
+                <asvg:svgBlip xmlns:asvg="http://schemas.microsoft.com/office/drawing/2016/SVG/main" r:embed="rId2"/>
               </a:ext>
             </a:extLst>
           </a:blip>
@@ -16642,11 +16642,11 @@
     <p:bg>
       <p:bgPr>
         <a:blipFill dpi="0" rotWithShape="1">
-          <a:blip r:embed="rId2">
+          <a:blip>
             <a:lum/>
             <a:extLst>
               <a:ext uri="{96DAC541-7B7A-43D3-8B79-37D633B846F1}">
-                <asvg:svgBlip xmlns:asvg="http://schemas.microsoft.com/office/drawing/2016/SVG/main" r:embed="rId3"/>
+                <asvg:svgBlip xmlns:asvg="http://schemas.microsoft.com/office/drawing/2016/SVG/main" r:embed="rId2"/>
               </a:ext>
             </a:extLst>
           </a:blip>
@@ -16804,11 +16804,11 @@
     <p:bg>
       <p:bgPr>
         <a:blipFill dpi="0" rotWithShape="1">
-          <a:blip r:embed="rId2">
+          <a:blip>
             <a:lum/>
             <a:extLst>
               <a:ext uri="{96DAC541-7B7A-43D3-8B79-37D633B846F1}">
-                <asvg:svgBlip xmlns:asvg="http://schemas.microsoft.com/office/drawing/2016/SVG/main" r:embed="rId3"/>
+                <asvg:svgBlip xmlns:asvg="http://schemas.microsoft.com/office/drawing/2016/SVG/main" r:embed="rId2"/>
               </a:ext>
             </a:extLst>
           </a:blip>
@@ -16961,11 +16961,11 @@
     <p:bg>
       <p:bgPr>
         <a:blipFill dpi="0" rotWithShape="1">
-          <a:blip r:embed="rId2">
+          <a:blip>
             <a:lum/>
             <a:extLst>
               <a:ext uri="{96DAC541-7B7A-43D3-8B79-37D633B846F1}">
-                <asvg:svgBlip xmlns:asvg="http://schemas.microsoft.com/office/drawing/2016/SVG/main" r:embed="rId3"/>
+                <asvg:svgBlip xmlns:asvg="http://schemas.microsoft.com/office/drawing/2016/SVG/main" r:embed="rId2"/>
               </a:ext>
             </a:extLst>
           </a:blip>
@@ -17126,11 +17126,11 @@
     <p:bg>
       <p:bgPr>
         <a:blipFill dpi="0" rotWithShape="1">
-          <a:blip r:embed="rId2">
+          <a:blip>
             <a:lum/>
             <a:extLst>
               <a:ext uri="{96DAC541-7B7A-43D3-8B79-37D633B846F1}">
-                <asvg:svgBlip xmlns:asvg="http://schemas.microsoft.com/office/drawing/2016/SVG/main" r:embed="rId3"/>
+                <asvg:svgBlip xmlns:asvg="http://schemas.microsoft.com/office/drawing/2016/SVG/main" r:embed="rId2"/>
               </a:ext>
             </a:extLst>
           </a:blip>
@@ -17331,11 +17331,11 @@
     <p:bg>
       <p:bgPr>
         <a:blipFill dpi="0" rotWithShape="1">
-          <a:blip r:embed="rId2">
+          <a:blip>
             <a:lum/>
             <a:extLst>
               <a:ext uri="{96DAC541-7B7A-43D3-8B79-37D633B846F1}">
-                <asvg:svgBlip xmlns:asvg="http://schemas.microsoft.com/office/drawing/2016/SVG/main" r:embed="rId3"/>
+                <asvg:svgBlip xmlns:asvg="http://schemas.microsoft.com/office/drawing/2016/SVG/main" r:embed="rId2"/>
               </a:ext>
             </a:extLst>
           </a:blip>
@@ -17506,11 +17506,11 @@
     <p:bg>
       <p:bgPr>
         <a:blipFill dpi="0" rotWithShape="1">
-          <a:blip r:embed="rId2">
+          <a:blip>
             <a:lum/>
             <a:extLst>
               <a:ext uri="{96DAC541-7B7A-43D3-8B79-37D633B846F1}">
-                <asvg:svgBlip xmlns:asvg="http://schemas.microsoft.com/office/drawing/2016/SVG/main" r:embed="rId3"/>
+                <asvg:svgBlip xmlns:asvg="http://schemas.microsoft.com/office/drawing/2016/SVG/main" r:embed="rId2"/>
               </a:ext>
             </a:extLst>
           </a:blip>
@@ -18826,10 +18826,10 @@
           <p:nvPr userDrawn="1"/>
         </p:nvPicPr>
         <p:blipFill>
-          <a:blip r:embed="rId3">
+          <a:blip>
             <a:extLst>
               <a:ext uri="{96DAC541-7B7A-43D3-8B79-37D633B846F1}">
-                <asvg:svgBlip xmlns:asvg="http://schemas.microsoft.com/office/drawing/2016/SVG/main" r:embed="rId4"/>
+                <asvg:svgBlip xmlns:asvg="http://schemas.microsoft.com/office/drawing/2016/SVG/main" r:embed="rId3"/>
               </a:ext>
             </a:extLst>
           </a:blip>
@@ -19582,10 +19582,10 @@
           <p:nvPr userDrawn="1"/>
         </p:nvPicPr>
         <p:blipFill>
-          <a:blip r:embed="rId2">
+          <a:blip>
             <a:extLst>
               <a:ext uri="{96DAC541-7B7A-43D3-8B79-37D633B846F1}">
-                <asvg:svgBlip xmlns:asvg="http://schemas.microsoft.com/office/drawing/2016/SVG/main" r:embed="rId3"/>
+                <asvg:svgBlip xmlns:asvg="http://schemas.microsoft.com/office/drawing/2016/SVG/main" r:embed="rId2"/>
               </a:ext>
             </a:extLst>
           </a:blip>
@@ -20462,11 +20462,11 @@
     <p:bg>
       <p:bgPr>
         <a:blipFill dpi="0" rotWithShape="1">
-          <a:blip r:embed="rId2">
+          <a:blip>
             <a:lum/>
             <a:extLst>
               <a:ext uri="{96DAC541-7B7A-43D3-8B79-37D633B846F1}">
-                <asvg:svgBlip xmlns:asvg="http://schemas.microsoft.com/office/drawing/2016/SVG/main" r:embed="rId3"/>
+                <asvg:svgBlip xmlns:asvg="http://schemas.microsoft.com/office/drawing/2016/SVG/main" r:embed="rId2"/>
               </a:ext>
             </a:extLst>
           </a:blip>
@@ -20724,11 +20724,11 @@
     <p:bg>
       <p:bgPr>
         <a:blipFill dpi="0" rotWithShape="1">
-          <a:blip r:embed="rId2">
+          <a:blip>
             <a:lum/>
             <a:extLst>
               <a:ext uri="{96DAC541-7B7A-43D3-8B79-37D633B846F1}">
-                <asvg:svgBlip xmlns:asvg="http://schemas.microsoft.com/office/drawing/2016/SVG/main" r:embed="rId3"/>
+                <asvg:svgBlip xmlns:asvg="http://schemas.microsoft.com/office/drawing/2016/SVG/main" r:embed="rId2"/>
               </a:ext>
             </a:extLst>
           </a:blip>
@@ -21093,10 +21093,10 @@
           <p:nvPr userDrawn="1"/>
         </p:nvPicPr>
         <p:blipFill>
-          <a:blip r:embed="rId4">
+          <a:blip>
             <a:extLst>
               <a:ext uri="{96DAC541-7B7A-43D3-8B79-37D633B846F1}">
-                <asvg:svgBlip xmlns:asvg="http://schemas.microsoft.com/office/drawing/2016/SVG/main" r:embed="rId5"/>
+                <asvg:svgBlip xmlns:asvg="http://schemas.microsoft.com/office/drawing/2016/SVG/main" r:embed="rId3"/>
               </a:ext>
             </a:extLst>
           </a:blip>
@@ -21530,11 +21530,11 @@
     <p:bg>
       <p:bgPr>
         <a:blipFill dpi="0" rotWithShape="1">
-          <a:blip r:embed="rId2">
+          <a:blip>
             <a:lum/>
             <a:extLst>
               <a:ext uri="{96DAC541-7B7A-43D3-8B79-37D633B846F1}">
-                <asvg:svgBlip xmlns:asvg="http://schemas.microsoft.com/office/drawing/2016/SVG/main" r:embed="rId3"/>
+                <asvg:svgBlip xmlns:asvg="http://schemas.microsoft.com/office/drawing/2016/SVG/main" r:embed="rId2"/>
               </a:ext>
             </a:extLst>
           </a:blip>
@@ -21861,11 +21861,11 @@
     <p:bg>
       <p:bgPr>
         <a:blipFill dpi="0" rotWithShape="1">
-          <a:blip r:embed="rId2">
+          <a:blip>
             <a:lum/>
             <a:extLst>
               <a:ext uri="{96DAC541-7B7A-43D3-8B79-37D633B846F1}">
-                <asvg:svgBlip xmlns:asvg="http://schemas.microsoft.com/office/drawing/2016/SVG/main" r:embed="rId3"/>
+                <asvg:svgBlip xmlns:asvg="http://schemas.microsoft.com/office/drawing/2016/SVG/main" r:embed="rId2"/>
               </a:ext>
             </a:extLst>
           </a:blip>
@@ -22357,10 +22357,10 @@
           <p:nvPr userDrawn="1"/>
         </p:nvPicPr>
         <p:blipFill>
-          <a:blip r:embed="rId56">
+          <a:blip>
             <a:extLst>
               <a:ext uri="{96DAC541-7B7A-43D3-8B79-37D633B846F1}">
-                <asvg:svgBlip xmlns:asvg="http://schemas.microsoft.com/office/drawing/2016/SVG/main" r:embed="rId57"/>
+                <asvg:svgBlip xmlns:asvg="http://schemas.microsoft.com/office/drawing/2016/SVG/main" r:embed="rId56"/>
               </a:ext>
             </a:extLst>
           </a:blip>
@@ -23246,7 +23246,12 @@
             <p:ph idx="1"/>
           </p:nvPr>
         </p:nvSpPr>
-        <p:spPr/>
+        <p:spPr>
+          <a:xfrm>
+            <a:off x="381599" y="972589"/>
+            <a:ext cx="11404800" cy="5290871"/>
+          </a:xfrm>
+        </p:spPr>
         <p:txBody>
           <a:bodyPr/>
           <a:lstStyle/>
@@ -23268,10 +23273,9 @@
               <a:t>moduleName</a:t>
             </a:r>
             <a:r>
-              <a:rPr lang="en-US"/>
+              <a:rPr lang="en-US" dirty="0"/>
               <a:t>}}</a:t>
             </a:r>
-            <a:endParaRPr lang="en-US" dirty="0"/>
           </a:p>
           <a:p>
             <a:r>

</xml_diff>